<commit_message>
Update Slide 3 with real project outputs (GIS telemetry & POLAR AI RAG) and export PDF
</commit_message>
<xml_diff>
--- a/presentation/POLARIS_SIH26063_Presentation_Final.pptx
+++ b/presentation/POLARIS_SIH26063_Presentation_Final.pptx
@@ -11454,7 +11454,13 @@
               </a:defRPr>
             </a:pPr>
             <a:r>
-              <a:t>Fig 1: POLARIS Interactive Station GIS &amp; Simulated Telemetry [DEMO DATA]</a:t>
+              <a:rPr sz="1050" b="1">
+                <a:solidFill>
+                  <a:srgbClr val="0A192F"/>
+                </a:solidFill>
+                <a:latin typeface="Arial"/>
+              </a:rPr>
+              <a:t>Fig 1: POLARIS Interactive Station GIS &amp; Live Telemetry Explorer [REAL PROJECT OUTPUT]</a:t>
             </a:r>
           </a:p>
         </p:txBody>
@@ -11489,7 +11495,13 @@
               </a:defRPr>
             </a:pPr>
             <a:r>
-              <a:t>Fig 2: POLARIS Citation-Grounded RAG Assistant &amp; Outreach Studio [PROTOTYPE UI - DEMO DATA]</a:t>
+              <a:rPr sz="1050" b="1">
+                <a:solidFill>
+                  <a:srgbClr val="0A192F"/>
+                </a:solidFill>
+                <a:latin typeface="Arial"/>
+              </a:rPr>
+              <a:t>Fig 2: POLARIS Evidence-Grounded RAG Assistant &amp; Citation Engine [REAL PROJECT OUTPUT]</a:t>
             </a:r>
           </a:p>
         </p:txBody>
@@ -11678,54 +11690,6 @@
           </p:txBody>
         </p:sp>
       </p:grpSp>
-      <p:pic>
-        <p:nvPicPr>
-          <p:cNvPr id="549" name="Picture 548" descr="image.png"/>
-          <p:cNvPicPr>
-            <a:picLocks noChangeAspect="1"/>
-          </p:cNvPicPr>
-          <p:nvPr/>
-        </p:nvPicPr>
-        <p:blipFill>
-          <a:blip r:embed="rId7"/>
-          <a:stretch>
-            <a:fillRect/>
-          </a:stretch>
-        </p:blipFill>
-        <p:spPr>
-          <a:xfrm>
-            <a:off x="12252960" y="1234440"/>
-            <a:ext cx="5897880" cy="3886200"/>
-          </a:xfrm>
-          <a:prstGeom prst="rect">
-            <a:avLst/>
-          </a:prstGeom>
-        </p:spPr>
-      </p:pic>
-      <p:pic>
-        <p:nvPicPr>
-          <p:cNvPr id="550" name="Picture 549" descr="image.png"/>
-          <p:cNvPicPr>
-            <a:picLocks noChangeAspect="1"/>
-          </p:cNvPicPr>
-          <p:nvPr/>
-        </p:nvPicPr>
-        <p:blipFill>
-          <a:blip r:embed="rId8"/>
-          <a:stretch>
-            <a:fillRect/>
-          </a:stretch>
-        </p:blipFill>
-        <p:spPr>
-          <a:xfrm>
-            <a:off x="12252960" y="5532120"/>
-            <a:ext cx="5897880" cy="3886200"/>
-          </a:xfrm>
-          <a:prstGeom prst="rect">
-            <a:avLst/>
-          </a:prstGeom>
-        </p:spPr>
-      </p:pic>
       <p:sp>
         <p:nvSpPr>
           <p:cNvPr id="551" name="TextBox 550"/>
@@ -15215,6 +15179,54 @@
           </a:p>
         </p:txBody>
       </p:sp>
+      <p:pic>
+        <p:nvPicPr>
+          <p:cNvPr id="614" name="Picture 613" descr="slide3_final_fig1.png"/>
+          <p:cNvPicPr>
+            <a:picLocks noChangeAspect="1"/>
+          </p:cNvPicPr>
+          <p:nvPr/>
+        </p:nvPicPr>
+        <p:blipFill>
+          <a:blip r:embed="rId9"/>
+          <a:stretch>
+            <a:fillRect/>
+          </a:stretch>
+        </p:blipFill>
+        <p:spPr>
+          <a:xfrm>
+            <a:off x="12252960" y="1234440"/>
+            <a:ext cx="5897880" cy="3886200"/>
+          </a:xfrm>
+          <a:prstGeom prst="rect">
+            <a:avLst/>
+          </a:prstGeom>
+        </p:spPr>
+      </p:pic>
+      <p:pic>
+        <p:nvPicPr>
+          <p:cNvPr id="615" name="Picture 614" descr="slide3_final_fig2_optionA.png"/>
+          <p:cNvPicPr>
+            <a:picLocks noChangeAspect="1"/>
+          </p:cNvPicPr>
+          <p:nvPr/>
+        </p:nvPicPr>
+        <p:blipFill>
+          <a:blip r:embed="rId10"/>
+          <a:stretch>
+            <a:fillRect/>
+          </a:stretch>
+        </p:blipFill>
+        <p:spPr>
+          <a:xfrm>
+            <a:off x="12252960" y="5532120"/>
+            <a:ext cx="5897880" cy="3886200"/>
+          </a:xfrm>
+          <a:prstGeom prst="rect">
+            <a:avLst/>
+          </a:prstGeom>
+        </p:spPr>
+      </p:pic>
     </p:spTree>
   </p:cSld>
   <p:clrMapOvr>

</xml_diff>